<commit_message>
feat: add presentation automation scripts, project documentation, and initial slide deck content
</commit_message>
<xml_diff>
--- a/presentation/deck/Smart Cities_PUP_ATLAN_PitchDeck.pptx
+++ b/presentation/deck/Smart Cities_PUP_ATLAN_PitchDeck.pptx
@@ -316,7 +316,7 @@
           <a:p>
             <a:fld id="{5BCAD085-E8A6-8845-BD4E-CB4CCA059FC4}" type="datetimeFigureOut">
               <a:rPr lang="en-US" smtClean="0"/>
-              <a:t>6/19/2026</a:t>
+              <a:t>6/23/2026</a:t>
             </a:fld>
             <a:endParaRPr lang="en-US"/>
           </a:p>
@@ -484,7 +484,7 @@
           <a:p>
             <a:fld id="{5BCAD085-E8A6-8845-BD4E-CB4CCA059FC4}" type="datetimeFigureOut">
               <a:rPr lang="en-US" smtClean="0"/>
-              <a:t>6/19/2026</a:t>
+              <a:t>6/23/2026</a:t>
             </a:fld>
             <a:endParaRPr lang="en-US"/>
           </a:p>
@@ -662,7 +662,7 @@
           <a:p>
             <a:fld id="{5BCAD085-E8A6-8845-BD4E-CB4CCA059FC4}" type="datetimeFigureOut">
               <a:rPr lang="en-US" smtClean="0"/>
-              <a:t>6/19/2026</a:t>
+              <a:t>6/23/2026</a:t>
             </a:fld>
             <a:endParaRPr lang="en-US"/>
           </a:p>
@@ -830,7 +830,7 @@
           <a:p>
             <a:fld id="{5BCAD085-E8A6-8845-BD4E-CB4CCA059FC4}" type="datetimeFigureOut">
               <a:rPr lang="en-US" smtClean="0"/>
-              <a:t>6/19/2026</a:t>
+              <a:t>6/23/2026</a:t>
             </a:fld>
             <a:endParaRPr lang="en-US"/>
           </a:p>
@@ -1075,7 +1075,7 @@
           <a:p>
             <a:fld id="{5BCAD085-E8A6-8845-BD4E-CB4CCA059FC4}" type="datetimeFigureOut">
               <a:rPr lang="en-US" smtClean="0"/>
-              <a:t>6/19/2026</a:t>
+              <a:t>6/23/2026</a:t>
             </a:fld>
             <a:endParaRPr lang="en-US"/>
           </a:p>
@@ -1360,7 +1360,7 @@
           <a:p>
             <a:fld id="{5BCAD085-E8A6-8845-BD4E-CB4CCA059FC4}" type="datetimeFigureOut">
               <a:rPr lang="en-US" smtClean="0"/>
-              <a:t>6/19/2026</a:t>
+              <a:t>6/23/2026</a:t>
             </a:fld>
             <a:endParaRPr lang="en-US"/>
           </a:p>
@@ -1779,7 +1779,7 @@
           <a:p>
             <a:fld id="{5BCAD085-E8A6-8845-BD4E-CB4CCA059FC4}" type="datetimeFigureOut">
               <a:rPr lang="en-US" smtClean="0"/>
-              <a:t>6/19/2026</a:t>
+              <a:t>6/23/2026</a:t>
             </a:fld>
             <a:endParaRPr lang="en-US"/>
           </a:p>
@@ -1896,7 +1896,7 @@
           <a:p>
             <a:fld id="{5BCAD085-E8A6-8845-BD4E-CB4CCA059FC4}" type="datetimeFigureOut">
               <a:rPr lang="en-US" smtClean="0"/>
-              <a:t>6/19/2026</a:t>
+              <a:t>6/23/2026</a:t>
             </a:fld>
             <a:endParaRPr lang="en-US"/>
           </a:p>
@@ -1991,7 +1991,7 @@
           <a:p>
             <a:fld id="{5BCAD085-E8A6-8845-BD4E-CB4CCA059FC4}" type="datetimeFigureOut">
               <a:rPr lang="en-US" smtClean="0"/>
-              <a:t>6/19/2026</a:t>
+              <a:t>6/23/2026</a:t>
             </a:fld>
             <a:endParaRPr lang="en-US"/>
           </a:p>
@@ -2266,7 +2266,7 @@
           <a:p>
             <a:fld id="{5BCAD085-E8A6-8845-BD4E-CB4CCA059FC4}" type="datetimeFigureOut">
               <a:rPr lang="en-US" smtClean="0"/>
-              <a:t>6/19/2026</a:t>
+              <a:t>6/23/2026</a:t>
             </a:fld>
             <a:endParaRPr lang="en-US"/>
           </a:p>
@@ -2518,7 +2518,7 @@
           <a:p>
             <a:fld id="{5BCAD085-E8A6-8845-BD4E-CB4CCA059FC4}" type="datetimeFigureOut">
               <a:rPr lang="en-US" smtClean="0"/>
-              <a:t>6/19/2026</a:t>
+              <a:t>6/23/2026</a:t>
             </a:fld>
             <a:endParaRPr lang="en-US"/>
           </a:p>
@@ -2729,7 +2729,7 @@
           <a:p>
             <a:fld id="{5BCAD085-E8A6-8845-BD4E-CB4CCA059FC4}" type="datetimeFigureOut">
               <a:rPr lang="en-US" smtClean="0"/>
-              <a:t>6/19/2026</a:t>
+              <a:t>6/23/2026</a:t>
             </a:fld>
             <a:endParaRPr lang="en-US"/>
           </a:p>
@@ -3223,6 +3223,63 @@
       </p:pic>
       <p:sp>
         <p:nvSpPr>
+          <p:cNvPr id="6" name="Rounded Rectangle 5"/>
+          <p:cNvSpPr/>
+          <p:nvPr/>
+        </p:nvSpPr>
+        <p:spPr>
+          <a:xfrm>
+            <a:off x="6446520" y="2331720"/>
+            <a:ext cx="5394960" cy="566928"/>
+          </a:xfrm>
+          <a:prstGeom prst="roundRect">
+            <a:avLst>
+              <a:gd name="adj" fmla="val 50000"/>
+            </a:avLst>
+          </a:prstGeom>
+          <a:solidFill>
+            <a:srgbClr val="0A1E55"/>
+          </a:solidFill>
+          <a:ln w="12700">
+            <a:solidFill>
+              <a:srgbClr val="3B82F6"/>
+            </a:solidFill>
+          </a:ln>
+          <a:effectLst/>
+        </p:spPr>
+        <p:style>
+          <a:lnRef idx="1">
+            <a:schemeClr val="accent1"/>
+          </a:lnRef>
+          <a:fillRef idx="3">
+            <a:schemeClr val="accent1"/>
+          </a:fillRef>
+          <a:effectRef idx="2">
+            <a:schemeClr val="accent1"/>
+          </a:effectRef>
+          <a:fontRef idx="minor">
+            <a:schemeClr val="lt1"/>
+          </a:fontRef>
+        </p:style>
+        <p:txBody>
+          <a:bodyPr wrap="none" lIns="36576" tIns="36576" rIns="36576" bIns="36576" rtlCol="0" anchor="ctr"/>
+          <a:lstStyle/>
+          <a:p>
+            <a:pPr algn="ctr"/>
+            <a:r>
+              <a:rPr sz="1500" b="1">
+                <a:solidFill>
+                  <a:srgbClr val="38BDF8"/>
+                </a:solidFill>
+                <a:latin typeface="Segoe UI Semibold"/>
+              </a:rPr>
+              <a:t>SMART CITIES  ·  ASEAN AI HACKATHON 2026</a:t>
+            </a:r>
+          </a:p>
+        </p:txBody>
+      </p:sp>
+      <p:sp>
+        <p:nvSpPr>
           <p:cNvPr id="7" name="TextBox 6"/>
           <p:cNvSpPr txBox="1"/>
           <p:nvPr/>
@@ -3321,7 +3378,7 @@
                 </a:solidFill>
                 <a:latin typeface="Segoe UI"/>
               </a:rPr>
-              <a:t>See a project’s full impact — </a:t>
+              <a:t>See a project’s full impact </a:t>
             </a:r>
             <a:r>
               <a:rPr sz="2500" b="1" i="0">
@@ -3675,7 +3732,7 @@
                 </a:solidFill>
                 <a:latin typeface="Segoe UI Semibold"/>
               </a:rPr>
-              <a:t>What broke — and how we made it honest.</a:t>
+              <a:t>What broke, and how we made it honest.</a:t>
             </a:r>
           </a:p>
         </p:txBody>
@@ -3972,7 +4029,7 @@
                 </a:solidFill>
                 <a:latin typeface="Segoe UI"/>
               </a:rPr>
-              <a:t>One unified kernel → a single trajectory dataset every module scores. They physically cannot diverge.</a:t>
+              <a:t>We built one unified kernel that generates a single trajectory dataset. Since every module scores the same data, they physically cannot diverge.</a:t>
             </a:r>
           </a:p>
         </p:txBody>
@@ -4199,7 +4256,7 @@
                 </a:solidFill>
                 <a:latin typeface="Segoe UI"/>
               </a:rPr>
-              <a:t>A glass-box contract + citation guard + an auditor that blocks the merge if any number ships unprovenanced.</a:t>
+              <a:t>We enforced a glass-box contract and citation guard. An auditor blocks the merge if any number ships without clear provenance.</a:t>
             </a:r>
           </a:p>
         </p:txBody>
@@ -4378,7 +4435,7 @@
                 </a:solidFill>
                 <a:latin typeface="Segoe UI"/>
               </a:rPr>
-              <a:t>A cold run still clocks ~123 s, over target.</a:t>
+              <a:t>A cold run still clocks around 123 seconds, which is over target.</a:t>
             </a:r>
           </a:p>
         </p:txBody>
@@ -4426,7 +4483,7 @@
                 </a:solidFill>
                 <a:latin typeface="Segoe UI"/>
               </a:rPr>
-              <a:t>Pre-warmed personas, delta-vs-baseline, parallel modules, and a trajectory cache — repeat runs return in &lt;1 s.</a:t>
+              <a:t>We introduced pre-warmed personas, delta-vs-baseline simulations, parallel modules, and a trajectory cache so repeat runs return in under a second.</a:t>
             </a:r>
           </a:p>
         </p:txBody>
@@ -4688,7 +4745,7 @@
                 </a:solidFill>
                 <a:latin typeface="Segoe UI"/>
               </a:rPr>
-              <a:t>Every stage is now measured and visible — we optimise against real numbers, and we say “target,” “planned,” and “provisional” out loud. That discipline is the brand.</a:t>
+              <a:t>Every stage is now measured and visible. We optimize against real numbers and are very transparent about what is a “target,” “planned,” or “provisional”. This kind of discipline is our brand.</a:t>
             </a:r>
           </a:p>
         </p:txBody>
@@ -4900,7 +4957,7 @@
                 </a:solidFill>
                 <a:latin typeface="Segoe UI Semibold"/>
               </a:rPr>
-              <a:t>Computed, not asserted — and honest about what isn’t ready.</a:t>
+              <a:t>Computed instead of asserted, and honest about what isn’t ready.</a:t>
             </a:r>
           </a:p>
         </p:txBody>
@@ -5005,7 +5062,7 @@
                 </a:solidFill>
                 <a:latin typeface="Segoe UI Semibold"/>
               </a:rPr>
-              <a:t>EFFICIENCY — MEASURED</a:t>
+              <a:t>EFFICIENCY: MEASURED</a:t>
             </a:r>
           </a:p>
         </p:txBody>
@@ -5067,8 +5124,8 @@
         </p:nvSpPr>
         <p:spPr>
           <a:xfrm>
-            <a:off x="640080" y="3127248"/>
-            <a:ext cx="3182112" cy="868680"/>
+            <a:off x="1764662" y="3223034"/>
+            <a:ext cx="932948" cy="677108"/>
           </a:xfrm>
           <a:prstGeom prst="rect">
             <a:avLst/>
@@ -5081,9 +5138,9 @@
           </a:bodyPr>
           <a:lstStyle/>
           <a:p>
-            <a:pPr algn="l"/>
-            <a:r>
-              <a:rPr sz="4400" b="1" i="0">
+            <a:pPr algn="ctr"/>
+            <a:r>
+              <a:rPr sz="4400" b="1" i="0" dirty="0">
                 <a:solidFill>
                   <a:srgbClr val="22C55E"/>
                 </a:solidFill>
@@ -5128,7 +5185,7 @@
                 </a:solidFill>
                 <a:latin typeface="Segoe UI"/>
               </a:rPr>
-              <a:t>kernel tests pass (1 skipped)</a:t>
+              <a:t>Kernel tests pass (1 skipped)</a:t>
             </a:r>
           </a:p>
         </p:txBody>
@@ -5190,8 +5247,8 @@
         </p:nvSpPr>
         <p:spPr>
           <a:xfrm>
-            <a:off x="4096511" y="3127248"/>
-            <a:ext cx="3182112" cy="868680"/>
+            <a:off x="5065602" y="3223034"/>
+            <a:ext cx="1243930" cy="677108"/>
           </a:xfrm>
           <a:prstGeom prst="rect">
             <a:avLst/>
@@ -5204,7 +5261,7 @@
           </a:bodyPr>
           <a:lstStyle/>
           <a:p>
-            <a:pPr algn="l"/>
+            <a:pPr algn="ctr"/>
             <a:r>
               <a:rPr sz="4400" b="1" i="0">
                 <a:solidFill>
@@ -5251,7 +5308,7 @@
                 </a:solidFill>
                 <a:latin typeface="Segoe UI"/>
               </a:rPr>
-              <a:t>end-to-end budget (target)</a:t>
+              <a:t>End-to-end budget target</a:t>
             </a:r>
           </a:p>
         </p:txBody>
@@ -5313,8 +5370,8 @@
         </p:nvSpPr>
         <p:spPr>
           <a:xfrm>
-            <a:off x="7552944" y="3127248"/>
-            <a:ext cx="3182112" cy="868680"/>
+            <a:off x="8522035" y="3223034"/>
+            <a:ext cx="1243930" cy="677108"/>
           </a:xfrm>
           <a:prstGeom prst="rect">
             <a:avLst/>
@@ -5327,7 +5384,7 @@
           </a:bodyPr>
           <a:lstStyle/>
           <a:p>
-            <a:pPr algn="l"/>
+            <a:pPr algn="ctr"/>
             <a:r>
               <a:rPr sz="4400" b="1" i="0">
                 <a:solidFill>
@@ -5374,7 +5431,7 @@
                 </a:solidFill>
                 <a:latin typeface="Segoe UI"/>
               </a:rPr>
-              <a:t>warm / cached repeat run</a:t>
+              <a:t>Warm or cached repeat run</a:t>
             </a:r>
           </a:p>
         </p:txBody>
@@ -5436,8 +5493,8 @@
         </p:nvSpPr>
         <p:spPr>
           <a:xfrm>
-            <a:off x="11009376" y="3127248"/>
-            <a:ext cx="3182112" cy="868680"/>
+            <a:off x="12444940" y="3223034"/>
+            <a:ext cx="310983" cy="677108"/>
           </a:xfrm>
           <a:prstGeom prst="rect">
             <a:avLst/>
@@ -5450,7 +5507,7 @@
           </a:bodyPr>
           <a:lstStyle/>
           <a:p>
-            <a:pPr algn="l"/>
+            <a:pPr algn="ctr"/>
             <a:r>
               <a:rPr sz="4400" b="1" i="0">
                 <a:solidFill>
@@ -5497,7 +5554,7 @@
                 </a:solidFill>
                 <a:latin typeface="Segoe UI"/>
               </a:rPr>
-              <a:t>dimensions, one kernel</a:t>
+              <a:t>Dimensions from one kernel</a:t>
             </a:r>
           </a:p>
         </p:txBody>
@@ -5559,8 +5616,8 @@
         </p:nvSpPr>
         <p:spPr>
           <a:xfrm>
-            <a:off x="14465807" y="3127248"/>
-            <a:ext cx="3182112" cy="868680"/>
+            <a:off x="15279406" y="3223034"/>
+            <a:ext cx="1554913" cy="677108"/>
           </a:xfrm>
           <a:prstGeom prst="rect">
             <a:avLst/>
@@ -5573,7 +5630,7 @@
           </a:bodyPr>
           <a:lstStyle/>
           <a:p>
-            <a:pPr algn="l"/>
+            <a:pPr algn="ctr"/>
             <a:r>
               <a:rPr sz="4400" b="1" i="0">
                 <a:solidFill>
@@ -5581,7 +5638,7 @@
                 </a:solidFill>
                 <a:latin typeface="Consolas"/>
               </a:rPr>
-              <a:t>~123 s</a:t>
+              <a:t>123 s</a:t>
             </a:r>
           </a:p>
         </p:txBody>
@@ -5620,7 +5677,7 @@
                 </a:solidFill>
                 <a:latin typeface="Segoe UI"/>
               </a:rPr>
-              <a:t>cold run — over target, honest</a:t>
+              <a:t>Cold run time, over target but honest</a:t>
             </a:r>
           </a:p>
         </p:txBody>
@@ -5655,7 +5712,7 @@
                 </a:solidFill>
                 <a:latin typeface="Segoe UI Semibold"/>
               </a:rPr>
-              <a:t>ACCURACY — A VALIDATION HARNESS THAT GRADES ITSELF</a:t>
+              <a:t>ACCURACY: A VALIDATION HARNESS THAT GRADES ITSELF</a:t>
             </a:r>
           </a:p>
         </p:txBody>
@@ -6421,7 +6478,7 @@
                 </a:solidFill>
                 <a:latin typeface="Segoe UI Semibold"/>
               </a:rPr>
-              <a:t>One city to ASEAN — a config change, not a rebuild.</a:t>
+              <a:t>Scaling from one city to all of ASEAN is a config change, not a rebuild.</a:t>
             </a:r>
           </a:p>
         </p:txBody>
@@ -6603,7 +6660,7 @@
                 </a:solidFill>
                 <a:latin typeface="Segoe UI Semibold"/>
               </a:rPr>
-              <a:t>The cost of a new ASEAN city is API tokens — not procurement.</a:t>
+              <a:t>The cost of adding a new ASEAN city is just API tokens, not expensive procurement.</a:t>
             </a:r>
           </a:p>
         </p:txBody>
@@ -7998,7 +8055,7 @@
                 </a:solidFill>
                 <a:latin typeface="Segoe UI"/>
               </a:rPr>
-              <a:t>Naming the local informal-transit modes — ojek, angkot, songthaew, tuk-tuk, xe-om — is exactly what imported Western planning tools cannot do.</a:t>
+              <a:t>Recognizing local informal transit modes like the ojek, angkot, songthaew, tuk-tuk, and xe-om is exactly what imported Western planning tools fail to do.</a:t>
             </a:r>
           </a:p>
         </p:txBody>
@@ -9170,7 +9227,7 @@
                 </a:solidFill>
                 <a:latin typeface="Segoe UI"/>
               </a:rPr>
-              <a:t>Flood-risk redistribution, climate exposure, and equity are scored pre-construction — not discovered on opening day.</a:t>
+              <a:t>Flood-risk redistribution, climate exposure, and equity are scored pre-construction rather than discovered on opening day.</a:t>
             </a:r>
           </a:p>
         </p:txBody>
@@ -9340,7 +9397,7 @@
                 </a:solidFill>
                 <a:latin typeface="Segoe UI"/>
               </a:rPr>
-              <a:t>Equity-weighted access and informal-worker displacement are scored, not assumed (SDG 10).</a:t>
+              <a:t>Equity-weighted access and informal-worker displacement are modeled and scored, not just assumed (SDG 10).</a:t>
             </a:r>
           </a:p>
         </p:txBody>
@@ -9510,7 +9567,7 @@
                 </a:solidFill>
                 <a:latin typeface="Segoe UI"/>
               </a:rPr>
-              <a:t>Confidence-anchored, auditable outputs are what data-sparse ASEAN cities need to trust a model.</a:t>
+              <a:t>Confidence-anchored and auditable outputs provide the transparency that data-sparse ASEAN cities need to trust a model.</a:t>
             </a:r>
           </a:p>
         </p:txBody>
@@ -9668,7 +9725,7 @@
                 </a:solidFill>
                 <a:latin typeface="Segoe UI"/>
               </a:rPr>
-              <a:t>Aligns with the ASEAN Smart Cities Network and the AAIH 2026 sustainability theme. A representative suburban-metro testbed — not a special case.</a:t>
+              <a:t>Aligns with the ASEAN Smart Cities Network and the AAIH 2026 sustainability theme. It serves as a representative suburban-metro testbed, not just an isolated special case.</a:t>
             </a:r>
           </a:p>
         </p:txBody>
@@ -9880,7 +9937,7 @@
                 </a:solidFill>
                 <a:latin typeface="Segoe UI Semibold"/>
               </a:rPr>
-              <a:t>After the hackathon: from prototype to pilot.</a:t>
+              <a:t>After the hackathon: moving from prototype to pilot.</a:t>
             </a:r>
           </a:p>
         </p:txBody>
@@ -10173,7 +10230,7 @@
                 </a:solidFill>
                 <a:latin typeface="Segoe UI Semibold"/>
               </a:rPr>
-              <a:t>NOW — close the loop</a:t>
+              <a:t>NOW: Close the loop</a:t>
             </a:r>
           </a:p>
         </p:txBody>
@@ -10212,7 +10269,7 @@
                 </a:solidFill>
                 <a:latin typeface="Segoe UI"/>
               </a:rPr>
-              <a:t>Calibrate mode-share → publish the VAL-01 RMSE · replace the provisional flood fixture → publish VAL-02 IoU · drive the cold run under 90 s (libsumo / headless).</a:t>
+              <a:t>Calibrate mode-share to publish the VAL-01 RMSE, replace the provisional flood fixture to publish VAL-02 IoU, and drive the cold run time under 90 seconds.</a:t>
             </a:r>
           </a:p>
         </p:txBody>
@@ -10390,7 +10447,7 @@
                 </a:solidFill>
                 <a:latin typeface="Segoe UI Semibold"/>
               </a:rPr>
-              <a:t>NEXT — deepen the model</a:t>
+              <a:t>NEXT: Deepen the model</a:t>
             </a:r>
           </a:p>
         </p:txBody>
@@ -10429,7 +10486,7 @@
                 </a:solidFill>
                 <a:latin typeface="Segoe UI"/>
               </a:rPr>
-              <a:t>Bias auditor: flag → reweight · Hiligaynon gazetteer (colloquial place-name → GIS node) · CPDO feedback loop (PRD-F20) · RAG ingestion pipeline.</a:t>
+              <a:t>Upgrade the bias auditor from flagging to reweighting, integrate a Hiligaynon gazetteer for colloquial place names, and establish a CPDO feedback loop.</a:t>
             </a:r>
           </a:p>
         </p:txBody>
@@ -10607,7 +10664,7 @@
                 </a:solidFill>
                 <a:latin typeface="Segoe UI Semibold"/>
               </a:rPr>
-              <a:t>PILOT — prove it in Iloilo</a:t>
+              <a:t>PILOT: Prove it in Iloilo</a:t>
             </a:r>
           </a:p>
         </p:txBody>
@@ -10646,7 +10703,7 @@
                 </a:solidFill>
                 <a:latin typeface="Segoe UI"/>
               </a:rPr>
-              <a:t>One real CPDO planner validates the demo → LGU + academic partnerships (Clean Air Asia, UP Visayas SURP) → a signed pilot scenario.</a:t>
+              <a:t>Have a real CPDO planner validate the demo, secure LGU and academic partnerships, and deliver a signed pilot scenario.</a:t>
             </a:r>
           </a:p>
         </p:txBody>
@@ -10824,7 +10881,7 @@
                 </a:solidFill>
                 <a:latin typeface="Segoe UI Semibold"/>
               </a:rPr>
-              <a:t>PRODUCT — sustain it</a:t>
+              <a:t>PRODUCT: Sustain it</a:t>
             </a:r>
           </a:p>
         </p:txBody>
@@ -10863,7 +10920,7 @@
                 </a:solidFill>
                 <a:latin typeface="Segoe UI"/>
               </a:rPr>
-              <a:t>Public-good free tier for LGUs &amp; academia; a paid private-developer / SaaS tier later. Deliberately TBD — adoption and credibility first.</a:t>
+              <a:t>Launch a public-good free tier for LGUs and academia, followed by a paid SaaS tier later. We are deliberately holding off on pricing to focus on adoption and credibility first.</a:t>
             </a:r>
           </a:p>
         </p:txBody>
@@ -12322,8 +12379,8 @@
         </p:nvSpPr>
         <p:spPr>
           <a:xfrm>
-            <a:off x="914400" y="7607808"/>
-            <a:ext cx="16459200" cy="1005840"/>
+            <a:off x="914400" y="7979923"/>
+            <a:ext cx="16459200" cy="261610"/>
           </a:xfrm>
           <a:prstGeom prst="rect">
             <a:avLst/>
@@ -12336,40 +12393,33 @@
           </a:bodyPr>
           <a:lstStyle/>
           <a:p>
-            <a:pPr algn="ctr">
-              <a:spcAft>
-                <a:spcPts val="600"/>
-              </a:spcAft>
-            </a:pPr>
-            <a:r>
-              <a:rPr sz="1700" b="1" i="0">
+            <a:pPr algn="ctr"/>
+            <a:r>
+              <a:rPr sz="1700" b="1" i="0" dirty="0">
                 <a:solidFill>
                   <a:srgbClr val="38BDF8"/>
                 </a:solidFill>
                 <a:latin typeface="Segoe UI Semibold"/>
               </a:rPr>
-              <a:t>Contact:  </a:t>
-            </a:r>
-            <a:r>
-              <a:rPr sz="1700" b="0" i="0">
-                <a:solidFill>
-                  <a:srgbClr val="FFFFFF"/>
-                </a:solidFill>
-                <a:latin typeface="Segoe UI"/>
-              </a:rPr>
-              <a:t>Carlos Jerico Dela Torre   ·   carlosjericodelatorre@gmail.com   ·   +63 949 636 9705</a:t>
-            </a:r>
-          </a:p>
-          <a:p>
-            <a:pPr algn="ctr"/>
-            <a:r>
-              <a:rPr sz="1700" b="1" i="0">
+              <a:t>MATRIX: </a:t>
+            </a:r>
+            <a:r>
+              <a:rPr lang="en-US" sz="1700" b="1" dirty="0">
                 <a:solidFill>
                   <a:srgbClr val="38BDF8"/>
                 </a:solidFill>
                 <a:latin typeface="Segoe UI Semibold"/>
               </a:rPr>
-              <a:t>MATRIX — decide before you build.</a:t>
+              <a:t>D</a:t>
+            </a:r>
+            <a:r>
+              <a:rPr sz="1700" b="1" i="0" dirty="0">
+                <a:solidFill>
+                  <a:srgbClr val="38BDF8"/>
+                </a:solidFill>
+                <a:latin typeface="Segoe UI Semibold"/>
+              </a:rPr>
+              <a:t>ecide before you build.</a:t>
             </a:r>
           </a:p>
         </p:txBody>
@@ -12710,7 +12760,7 @@
                 </a:solidFill>
                 <a:latin typeface="Segoe UI"/>
               </a:rPr>
-              <a:t>ASEAN is in its largest urban build-out in history — and infrastructure is still approved on static feasibility studies that age the day they are filed. The damage shows up on opening day.</a:t>
+              <a:t>ASEAN is going through its largest urban build-out in history, yet infrastructure is still approved using static feasibility studies that age the day they are filed. The real damage only shows up on opening day.</a:t>
             </a:r>
           </a:p>
         </p:txBody>
@@ -13364,7 +13414,7 @@
                 </a:solidFill>
                 <a:latin typeface="Segoe UI"/>
               </a:rPr>
-              <a:t>the commuter who loses 25–35% of the fare to first-mile travel no one modeled  ·  the informal vendor paved over because no one ran the displacement scenario  ·  the barangay that floods because runoff was calculated in isolation.</a:t>
+              <a:t>the commuter who loses up to a third of their fare to unmodeled first-mile travel  ·  the informal vendor who gets paved over without a displacement plan  ·  the barangay that floods because runoff was calculated in isolation.</a:t>
             </a:r>
           </a:p>
         </p:txBody>
@@ -13399,7 +13449,7 @@
                 </a:solidFill>
                 <a:latin typeface="Segoe UI"/>
               </a:rPr>
-              <a:t>Illustrative of a documented pattern (Montalbo, UP SURP; JICA 2014/2019; ICLEI Iloilo Roadmap) — shown as a pattern, not as cited point statistics.</a:t>
+              <a:t>Illustrative of a documented pattern (Montalbo, UP SURP; JICA 2014/2019; ICLEI Iloilo Roadmap), shown as a general trend rather than cited point statistics.</a:t>
             </a:r>
           </a:p>
         </p:txBody>
@@ -13716,7 +13766,7 @@
                 </a:solidFill>
                 <a:latin typeface="Segoe UI"/>
               </a:rPr>
-              <a:t>A planner asks in plain language — </a:t>
+              <a:t>A planner asks in plain language, </a:t>
             </a:r>
             <a:r>
               <a:rPr sz="1750" b="1" i="0">
@@ -13734,7 +13784,7 @@
                 </a:solidFill>
                 <a:latin typeface="Segoe UI"/>
               </a:rPr>
-              <a:t>  — or drops a pin. One unified kernel simulates thousands of agents; five impact modules score the same reality; the map animates and a cited narrative explains it.</a:t>
+              <a:t> or simply drops a pin. A single unified kernel simulates thousands of agents while five impact modules score the same reality. The map animates, and a cited narrative explains the results.</a:t>
             </a:r>
           </a:p>
         </p:txBody>
@@ -13956,7 +14006,7 @@
                 </a:solidFill>
                 <a:latin typeface="Segoe UI Semibold"/>
               </a:rPr>
-              <a:t>Gemini orchestrator
+              <a:t>Azure OpenAI orchestrator
 parses the scenario</a:t>
             </a:r>
           </a:p>
@@ -14394,7 +14444,7 @@
                 </a:solidFill>
                 <a:latin typeface="Segoe UI Semibold"/>
               </a:rPr>
-              <a:t>ONE SIMULATED REALITY, SCORED FIVE WAYS — EACH WITH AN EXPLICIT CONFIDENCE LEVEL</a:t>
+              <a:t>ONE SIMULATED REALITY, SCORED FIVE WAYS WITH EXPLICIT CONFIDENCE LEVELS</a:t>
             </a:r>
           </a:p>
         </p:txBody>
@@ -16121,7 +16171,7 @@
                 </a:solidFill>
                 <a:latin typeface="Segoe UI Semibold"/>
               </a:rPr>
-              <a:t>—</a:t>
+              <a:t>No</a:t>
             </a:r>
           </a:p>
         </p:txBody>
@@ -16203,7 +16253,7 @@
                 </a:solidFill>
                 <a:latin typeface="Segoe UI Semibold"/>
               </a:rPr>
-              <a:t>—</a:t>
+              <a:t>No</a:t>
             </a:r>
           </a:p>
         </p:txBody>
@@ -16285,7 +16335,7 @@
                 </a:solidFill>
                 <a:latin typeface="Segoe UI Semibold"/>
               </a:rPr>
-              <a:t>—</a:t>
+              <a:t>No</a:t>
             </a:r>
           </a:p>
         </p:txBody>
@@ -16367,7 +16417,7 @@
                 </a:solidFill>
                 <a:latin typeface="Segoe UI Semibold"/>
               </a:rPr>
-              <a:t>—</a:t>
+              <a:t>No</a:t>
             </a:r>
           </a:p>
         </p:txBody>
@@ -16531,7 +16581,7 @@
                 </a:solidFill>
                 <a:latin typeface="Segoe UI Semibold"/>
               </a:rPr>
-              <a:t>—</a:t>
+              <a:t>No</a:t>
             </a:r>
           </a:p>
         </p:txBody>
@@ -16613,7 +16663,7 @@
                 </a:solidFill>
                 <a:latin typeface="Segoe UI Semibold"/>
               </a:rPr>
-              <a:t>—</a:t>
+              <a:t>No</a:t>
             </a:r>
           </a:p>
         </p:txBody>
@@ -16695,7 +16745,7 @@
                 </a:solidFill>
                 <a:latin typeface="Segoe UI Semibold"/>
               </a:rPr>
-              <a:t>—</a:t>
+              <a:t>No</a:t>
             </a:r>
           </a:p>
         </p:txBody>
@@ -16777,7 +16827,7 @@
                 </a:solidFill>
                 <a:latin typeface="Segoe UI Semibold"/>
               </a:rPr>
-              <a:t>—</a:t>
+              <a:t>No</a:t>
             </a:r>
           </a:p>
         </p:txBody>
@@ -16941,7 +16991,7 @@
                 </a:solidFill>
                 <a:latin typeface="Segoe UI Semibold"/>
               </a:rPr>
-              <a:t>—</a:t>
+              <a:t>No</a:t>
             </a:r>
           </a:p>
         </p:txBody>
@@ -17105,7 +17155,7 @@
                 </a:solidFill>
                 <a:latin typeface="Segoe UI Semibold"/>
               </a:rPr>
-              <a:t>—</a:t>
+              <a:t>No</a:t>
             </a:r>
           </a:p>
         </p:txBody>
@@ -17351,7 +17401,7 @@
                 </a:solidFill>
                 <a:latin typeface="Segoe UI Semibold"/>
               </a:rPr>
-              <a:t>—</a:t>
+              <a:t>No</a:t>
             </a:r>
           </a:p>
         </p:txBody>
@@ -17515,7 +17565,7 @@
                 </a:solidFill>
                 <a:latin typeface="Segoe UI Semibold"/>
               </a:rPr>
-              <a:t>—</a:t>
+              <a:t>No</a:t>
             </a:r>
           </a:p>
         </p:txBody>
@@ -17597,7 +17647,7 @@
                 </a:solidFill>
                 <a:latin typeface="Segoe UI Semibold"/>
               </a:rPr>
-              <a:t>—</a:t>
+              <a:t>No</a:t>
             </a:r>
           </a:p>
         </p:txBody>
@@ -18042,7 +18092,7 @@
                 </a:solidFill>
                 <a:latin typeface="Segoe UI"/>
               </a:rPr>
-              <a:t>Based on our competitor feature survey (GTM §2.1) — a combination claim, not an unfalsifiable absolute.</a:t>
+              <a:t>Based on our competitor feature survey (GTM §2.1). This represents a combination of features rather than an unfalsifiable absolute.</a:t>
             </a:r>
           </a:p>
         </p:txBody>
@@ -18173,7 +18223,7 @@
                 </a:solidFill>
                 <a:latin typeface="Segoe UI Semibold"/>
               </a:rPr>
-              <a:t>One kernel → five dimensions</a:t>
+              <a:t>One kernel to five dimensions</a:t>
             </a:r>
           </a:p>
         </p:txBody>
@@ -18212,7 +18262,7 @@
                 </a:solidFill>
                 <a:latin typeface="Segoe UI"/>
               </a:rPr>
-              <a:t>All five score the same simulated reality, so they can never contradict each other.</a:t>
+              <a:t>All five modules score the exact same simulated reality, meaning they will never contradict each other.</a:t>
             </a:r>
           </a:p>
         </p:txBody>
@@ -18343,7 +18393,7 @@
                 </a:solidFill>
                 <a:latin typeface="Segoe UI Semibold"/>
               </a:rPr>
-              <a:t>Glass box, by contract</a:t>
+              <a:t>Glass box by contract</a:t>
             </a:r>
           </a:p>
         </p:txBody>
@@ -18382,7 +18432,7 @@
                 </a:solidFill>
                 <a:latin typeface="Segoe UI"/>
               </a:rPr>
-              <a:t>Every number resolves to its equation, its datasets, and a computed confidence. The LLM narrates — it never invents a number.</a:t>
+              <a:t>Every single number resolves to its exact equation, datasets, and a computed confidence. The AI narrates the results but never invents a number.</a:t>
             </a:r>
           </a:p>
         </p:txBody>
@@ -18513,7 +18563,7 @@
                 </a:solidFill>
                 <a:latin typeface="Segoe UI Semibold"/>
               </a:rPr>
-              <a:t>Plain language → 90 seconds</a:t>
+              <a:t>Plain language to 90 seconds</a:t>
             </a:r>
           </a:p>
         </p:txBody>
@@ -18552,7 +18602,7 @@
                 </a:solidFill>
                 <a:latin typeface="Segoe UI"/>
               </a:rPr>
-              <a:t>A pin or a sentence in; a calibrated, confidence-anchored five-dimension answer out.</a:t>
+              <a:t>Provide a pin or a sentence and receive a calibrated, confidence-anchored five-dimension answer.</a:t>
             </a:r>
           </a:p>
         </p:txBody>
@@ -19396,7 +19446,7 @@
                 </a:solidFill>
                 <a:latin typeface="Segoe UI Semibold"/>
               </a:rPr>
-              <a:t>Gemini 3.1 Orchestrator</a:t>
+              <a:t>Azure OpenAI Orchestrator</a:t>
             </a:r>
           </a:p>
         </p:txBody>
@@ -20128,7 +20178,7 @@
                 </a:solidFill>
                 <a:latin typeface="Segoe UI"/>
               </a:rPr>
-              <a:t>Deck.gl TripsLayer — agents re-routing in real time</a:t>
+              <a:t>Deck.gl TripsLayer showing agents re-routing in real time</a:t>
             </a:r>
           </a:p>
         </p:txBody>
@@ -20183,7 +20233,7 @@
                 </a:solidFill>
                 <a:latin typeface="Segoe UI"/>
               </a:rPr>
-              <a:t>each with a High / Medium / Low confidence band</a:t>
+              <a:t>Each dimension comes with a High, Medium, or Low confidence band</a:t>
             </a:r>
           </a:p>
         </p:txBody>
@@ -20238,7 +20288,7 @@
                 </a:solidFill>
                 <a:latin typeface="Segoe UI"/>
               </a:rPr>
-              <a:t>click any number → equation + datasets + confidence</a:t>
+              <a:t>Click any number to view its equation, datasets, and confidence</a:t>
             </a:r>
           </a:p>
         </p:txBody>
@@ -20293,7 +20343,7 @@
                 </a:solidFill>
                 <a:latin typeface="Segoe UI"/>
               </a:rPr>
-              <a:t>a structured recommendation for the planner</a:t>
+              <a:t>A structured and easy-to-read recommendation for the planner</a:t>
             </a:r>
           </a:p>
         </p:txBody>
@@ -20418,7 +20468,7 @@
                 </a:solidFill>
                 <a:latin typeface="Segoe UI"/>
               </a:rPr>
-              <a:t>Engineered to a 90-second end-to-end budget: pre-warmed personas, delta simulation vs a nightly baseline, parallel modules, and a streaming progressive UI.</a:t>
+              <a:t>Engineered to a 90-second end-to-end budget: pre-warmed personas, delta simulation against a nightly baseline, parallel modules, and a streaming progressive UI.</a:t>
             </a:r>
           </a:p>
         </p:txBody>
@@ -21059,7 +21109,7 @@
                 </a:solidFill>
                 <a:latin typeface="Segoe UI Semibold"/>
               </a:rPr>
-              <a:t>Gemini 3.1 Pro</a:t>
+              <a:t>Azure OpenAI GPT-5.4</a:t>
             </a:r>
           </a:p>
         </p:txBody>
@@ -21133,7 +21183,7 @@
                 </a:solidFill>
                 <a:latin typeface="Segoe UI"/>
               </a:rPr>
-              <a:t>Parses plain language into a sim plan; writes the cited narrative. Current generation — 1.5 and 2.0 are shut down.</a:t>
+              <a:t>Parses plain language into a simulation plan and writes the cited narrative. We use the current generation since older models are shut down.</a:t>
             </a:r>
           </a:p>
         </p:txBody>
@@ -21264,7 +21314,7 @@
                 </a:solidFill>
                 <a:latin typeface="Segoe UI Semibold"/>
               </a:rPr>
-              <a:t>Gemini 3.1 Flash-Lite</a:t>
+              <a:t>Azure OpenAI GPT-5.4</a:t>
             </a:r>
           </a:p>
         </p:txBody>
@@ -21338,7 +21388,7 @@
                 </a:solidFill>
                 <a:latin typeface="Segoe UI"/>
               </a:rPr>
-              <a:t>200–500 commuter personas on the free tier — cheap and fast enough to pre-warm the pool.</a:t>
+              <a:t>Creates 200 to 500 commuter personas on the free tier, making it cheap and fast enough to pre-warm the pool.</a:t>
             </a:r>
           </a:p>
         </p:txBody>
@@ -21543,7 +21593,7 @@
                 </a:solidFill>
                 <a:latin typeface="Segoe UI"/>
               </a:rPr>
-              <a:t>The open urban-mobility standard (DLR). Not OASIS / MiroFish — those model social media, not cities.</a:t>
+              <a:t>The open urban-mobility standard from DLR. Unlike OASIS or MiroFish, which model social media, SUMO models actual cities.</a:t>
             </a:r>
           </a:p>
         </p:txBody>
@@ -21748,7 +21798,7 @@
                 </a:solidFill>
                 <a:latin typeface="Segoe UI"/>
               </a:rPr>
-              <a:t>Time-series forecaster for the nightly baseline that delta simulations run against.</a:t>
+              <a:t>A time-series forecaster that generates the nightly baseline for our delta simulations to run against.</a:t>
             </a:r>
           </a:p>
         </p:txBody>
@@ -22920,7 +22970,7 @@
                 </a:solidFill>
                 <a:latin typeface="Segoe UI"/>
               </a:rPr>
-              <a:t>LTFRB Region VI routes · PSA APIS poverty · Iloilo City CLUP 2021–2029 — filed Day 1; open substitutes used until they arrive</a:t>
+              <a:t>LTFRB Region VI routes · PSA APIS poverty · Iloilo City CLUP 2021-2029 requests filed on Day 1. Open substitutes are used until they arrive.</a:t>
             </a:r>
           </a:p>
         </p:txBody>
@@ -23090,7 +23140,7 @@
                 </a:solidFill>
                 <a:latin typeface="Segoe UI"/>
               </a:rPr>
-              <a:t>Calderon 2014 BRT corridor model · Macalalag 2021 bike study — anchors for validation</a:t>
+              <a:t>Calderon 2014 BRT corridor model and Macalalag 2021 bike study serve as our anchors for validation.</a:t>
             </a:r>
           </a:p>
         </p:txBody>
@@ -23225,7 +23275,7 @@
                 </a:solidFill>
                 <a:latin typeface="Segoe UI"/>
               </a:rPr>
-              <a:t>ODbL attribution, PSA &amp; ESA open terms — no scraping behind blocks.</a:t>
+              <a:t>We respect ODbL attribution and PSA/ESA open terms, with absolutely no scraping behind blocks.</a:t>
             </a:r>
           </a:p>
           <a:p>
@@ -23482,7 +23532,7 @@
                 </a:solidFill>
                 <a:latin typeface="Segoe UI"/>
               </a:rPr>
-              <a:t>pilot-city footprint — a full behavioral model</a:t>
+              <a:t>Pilot-city footprint with a full behavioral model</a:t>
             </a:r>
           </a:p>
         </p:txBody>
@@ -24082,7 +24132,7 @@
                 </a:solidFill>
                 <a:latin typeface="Segoe UI"/>
               </a:rPr>
-              <a:t>The bias auditor anchors generated persona mode-share to ground-truth mode-share and logs every deviation to a public audit. (Today it flags and surfaces; automated reweighting is on the roadmap — we say so.)</a:t>
+              <a:t>The bias auditor anchors generated persona mode-share to ground-truth mode-share and logs every deviation to a public audit. (Today it flags and surfaces; automated reweighting is on the roadmap and we say so.)</a:t>
             </a:r>
           </a:p>
         </p:txBody>
@@ -24252,7 +24302,7 @@
                 </a:solidFill>
                 <a:latin typeface="Segoe UI"/>
               </a:rPr>
-              <a:t>Every dimension advertises a confidence floor and reports ranges, never a fake point estimate — the safeguard data-sparse ASEAN cities actually need.</a:t>
+              <a:t>Every dimension advertises a confidence floor and reports ranges instead of fake point estimates. This is the safeguard that data-sparse ASEAN cities truly need.</a:t>
             </a:r>
           </a:p>
         </p:txBody>
@@ -24422,7 +24472,7 @@
                 </a:solidFill>
                 <a:latin typeface="Segoe UI"/>
               </a:rPr>
-              <a:t>Jeepney, tricycle, and street-vendor displacement are modelled explicitly in Social and Economic — exactly what imported Western tools omit.</a:t>
+              <a:t>Jeepney, tricycle, and street-vendor displacement are modelled explicitly in Social and Economic modules, which is exactly what imported Western tools omit.</a:t>
             </a:r>
           </a:p>
         </p:txBody>
@@ -24592,7 +24642,7 @@
                 </a:solidFill>
                 <a:latin typeface="Segoe UI"/>
               </a:rPr>
-              <a:t>No personal data in the pipeline — open and aggregate sources only. The optional GPS-trace companion app is gated behind a Privacy Impact Assessment and counsel.</a:t>
+              <a:t>No personal data exists in the pipeline, as we use open and aggregate sources only. The optional GPS-trace companion app is gated behind a Privacy Impact Assessment and counsel.</a:t>
             </a:r>
           </a:p>
         </p:txBody>
@@ -25077,7 +25127,7 @@
         <p:spPr>
           <a:xfrm>
             <a:off x="640080" y="4754880"/>
-            <a:ext cx="10241280" cy="1097280"/>
+            <a:ext cx="10241280" cy="338554"/>
           </a:xfrm>
           <a:prstGeom prst="rect">
             <a:avLst/>
@@ -25096,26 +25146,29 @@
               </a:spcAft>
             </a:pPr>
             <a:r>
-              <a:rPr sz="2200" b="1" i="0">
+              <a:rPr sz="2200" b="1" i="0" dirty="0">
                 <a:solidFill>
                   <a:srgbClr val="38BDF8"/>
                 </a:solidFill>
                 <a:latin typeface="Segoe UI Semibold"/>
               </a:rPr>
-              <a:t>▶  LIVE DEMO / GIF</a:t>
-            </a:r>
-          </a:p>
-          <a:p>
-            <a:pPr algn="ctr"/>
-            <a:r>
-              <a:rPr sz="1400" b="0" i="0">
-                <a:solidFill>
-                  <a:srgbClr val="9DB2DA"/>
-                </a:solidFill>
-                <a:latin typeface="Segoe UI"/>
-              </a:rPr>
-              <a:t>Deck.gl TripsLayer — simulated commuters re-routing around the new project</a:t>
-            </a:r>
+              <a:t>▶  LIVE DEMO </a:t>
+            </a:r>
+            <a:r>
+              <a:rPr lang="en-US" sz="2200" b="1" i="0" dirty="0">
+                <a:solidFill>
+                  <a:srgbClr val="38BDF8"/>
+                </a:solidFill>
+                <a:latin typeface="Segoe UI Semibold"/>
+              </a:rPr>
+              <a:t>PLACEHOLDER</a:t>
+            </a:r>
+            <a:endParaRPr sz="2200" b="1" i="0" dirty="0">
+              <a:solidFill>
+                <a:srgbClr val="38BDF8"/>
+              </a:solidFill>
+              <a:latin typeface="Segoe UI Semibold"/>
+            </a:endParaRPr>
           </a:p>
         </p:txBody>
       </p:sp>
@@ -25423,7 +25476,7 @@
                 </a:solidFill>
                 <a:latin typeface="Segoe UI"/>
               </a:rPr>
-              <a:t>Plain-language query → Gemini sim plan</a:t>
+              <a:t>Plain-language query → Azure OpenAI sim plan</a:t>
             </a:r>
           </a:p>
         </p:txBody>

</xml_diff>